<commit_message>
ingest+build: 다운턴 복기를 전체 메모리(DRAM+NAND)로 확장 (v2.46.3)
- sources: NAND 산업 연매출 2006~2025 시계열·분기 전환점 10건·다운턴별
  NAND 동행 판정·도시바 2012 감산 리서치 노트 신설
- wiki/downturn/downturn-history.md: 타임라인 D/N/전체 3열, 비교표 낙폭
  전체·D·N 분리, 프로필 5건 NAND 동행 문단, 패턴 6(NAND 완충 소멸) 신설
- downturn-review.pptx: 타임라인·미니 차트 D+N 스택 전환(DT16 = DRAM 단독
  다운턴 시각화), 표 낙폭 2단, 인사이트 밴드 4종, 보충 5장 NAND 불릿,
  산점도 DRAM 기준 명시. validate PASS·렌더 QA 완료
- dashboard: knowledgeGraph.js 재생성(엣지 546), version v2.46.3, 빌드 검증
- index.md·log.md·downturn-review-outline.md 갱신

Co-Authored-By: Claude <noreply@anthropic.com>
Claude-Session: https://claude.ai/code/session_01DGYn1XCUKFXj1Uc6AejDJQ
</commit_message>
<xml_diff>
--- a/outputs/presentation/downturn-review.pptx
+++ b/outputs/presentation/downturn-review.pptx
@@ -3288,7 +3288,7 @@
                 <a:latin typeface="Arial"/>
                 <a:ea typeface="Arial"/>
               </a:rPr>
-              <a:t>DRAM 산업 연매출 기준 낙폭 -11%에서 -45%까지. 과점화는 기간을 절반으로 줄였지만 깊이와 속도는 막지 못했다</a:t>
+              <a:t>DRAM+NAND 합산. NAND는 침투기(DT12·16)엔 완충, DT19부터 완전 동조: 전체 산업이 한 몸으로 떨어진다</a:t>
             </a:r>
           </a:p>
         </p:txBody>
@@ -3540,7 +3540,7 @@
                 <a:latin typeface="Arial"/>
                 <a:ea typeface="Arial"/>
               </a:rPr>
-              <a:t>규모</a:t>
+              <a:t>낙폭(전체·D·N)</a:t>
             </a:r>
           </a:p>
         </p:txBody>
@@ -3841,7 +3841,7 @@
                 <a:latin typeface="Arial"/>
                 <a:ea typeface="Arial"/>
               </a:rPr>
-              <a:t>-34%*</a:t>
+              <a:t>-26%*</a:t>
             </a:r>
           </a:p>
           <a:p>
@@ -3858,7 +3858,7 @@
                 <a:latin typeface="Arial"/>
                 <a:ea typeface="Arial"/>
               </a:rPr>
-              <a:t>최악 -36%</a:t>
+              <a:t>D -34 · N -14</a:t>
             </a:r>
           </a:p>
         </p:txBody>
@@ -4159,7 +4159,7 @@
                 <a:latin typeface="Arial"/>
                 <a:ea typeface="Arial"/>
               </a:rPr>
-              <a:t>-33%*</a:t>
+              <a:t>-19%*</a:t>
             </a:r>
           </a:p>
           <a:p>
@@ -4176,7 +4176,7 @@
                 <a:latin typeface="Arial"/>
                 <a:ea typeface="Arial"/>
               </a:rPr>
-              <a:t>최악 -20%</a:t>
+              <a:t>D -33 · N -2</a:t>
             </a:r>
           </a:p>
         </p:txBody>
@@ -4477,7 +4477,7 @@
                 <a:latin typeface="Arial"/>
                 <a:ea typeface="Arial"/>
               </a:rPr>
-              <a:t>-11%*</a:t>
+              <a:t>+2%*</a:t>
             </a:r>
           </a:p>
           <a:p>
@@ -4494,7 +4494,7 @@
                 <a:latin typeface="Arial"/>
                 <a:ea typeface="Arial"/>
               </a:rPr>
-              <a:t>최악 -9.1%</a:t>
+              <a:t>D -11 · N +14</a:t>
             </a:r>
           </a:p>
         </p:txBody>
@@ -4795,7 +4795,7 @@
                 <a:latin typeface="Arial"/>
                 <a:ea typeface="Arial"/>
               </a:rPr>
-              <a:t>-37.6%</a:t>
+              <a:t>-34%*</a:t>
             </a:r>
           </a:p>
           <a:p>
@@ -4812,7 +4812,7 @@
                 <a:latin typeface="Arial"/>
                 <a:ea typeface="Arial"/>
               </a:rPr>
-              <a:t>최악 -18.3%</a:t>
+              <a:t>D -37.6 · N -27</a:t>
             </a:r>
           </a:p>
         </p:txBody>
@@ -5130,7 +5130,7 @@
                 <a:latin typeface="Arial"/>
                 <a:ea typeface="Arial"/>
               </a:rPr>
-              <a:t>최악 -32.5%</a:t>
+              <a:t>D -45 · N -45</a:t>
             </a:r>
           </a:p>
         </p:txBody>
@@ -5268,7 +5268,7 @@
         <p:spPr>
           <a:xfrm>
             <a:off x="996696" y="9107424"/>
-            <a:ext cx="5202936" cy="512064"/>
+            <a:ext cx="3799332" cy="512064"/>
           </a:xfrm>
           <a:prstGeom prst="rect">
             <a:avLst/>
@@ -5287,14 +5287,14 @@
               </a:lnSpc>
             </a:pPr>
             <a:r>
-              <a:rPr sz="1575" b="1">
+              <a:rPr sz="1500" b="1">
                 <a:solidFill>
                   <a:srgbClr val="FFFFFF"/>
                 </a:solidFill>
                 <a:latin typeface="Arial"/>
                 <a:ea typeface="Arial"/>
               </a:rPr>
-              <a:t>① 발원이 기간을 결정: 공급발 9분기, 수요발 5-6분기</a:t>
+              <a:t>① 발원이 기간 결정: 공급 9, 수요 5-6분기</a:t>
             </a:r>
           </a:p>
         </p:txBody>
@@ -5307,8 +5307,8 @@
         </p:nvSpPr>
         <p:spPr>
           <a:xfrm>
-            <a:off x="6611112" y="9107424"/>
-            <a:ext cx="5202936" cy="512064"/>
+            <a:off x="5207508" y="9107424"/>
+            <a:ext cx="3799332" cy="512064"/>
           </a:xfrm>
           <a:prstGeom prst="rect">
             <a:avLst/>
@@ -5327,14 +5327,14 @@
               </a:lnSpc>
             </a:pPr>
             <a:r>
-              <a:rPr sz="1575" b="1">
+              <a:rPr sz="1500" b="1">
                 <a:solidFill>
                   <a:srgbClr val="FFFFFF"/>
                 </a:solidFill>
                 <a:latin typeface="Arial"/>
                 <a:ea typeface="Arial"/>
               </a:rPr>
-              <a:t>② 낙폭 -33 → -38 → -45%: 과점화도 깊이는 못 막았다</a:t>
+              <a:t>② 낙폭 확대: -26 → -34 → -45% (전체)</a:t>
             </a:r>
           </a:p>
         </p:txBody>
@@ -5347,8 +5347,8 @@
         </p:nvSpPr>
         <p:spPr>
           <a:xfrm>
-            <a:off x="12225528" y="9107424"/>
-            <a:ext cx="5202936" cy="512064"/>
+            <a:off x="9418320" y="9107424"/>
+            <a:ext cx="3799332" cy="512064"/>
           </a:xfrm>
           <a:prstGeom prst="rect">
             <a:avLst/>
@@ -5367,14 +5367,14 @@
               </a:lnSpc>
             </a:pPr>
             <a:r>
-              <a:rPr sz="1575" b="1">
+              <a:rPr sz="1500" b="1">
                 <a:solidFill>
                   <a:srgbClr val="FFFFFF"/>
                 </a:solidFill>
                 <a:latin typeface="Arial"/>
                 <a:ea typeface="Arial"/>
               </a:rPr>
-              <a:t>③ 직전 성공이 다음 함정: 2019 무감산·HBM 축소</a:t>
+              <a:t>③ NAND: 침투기 완충 → DT19부터 동조</a:t>
             </a:r>
           </a:p>
         </p:txBody>
@@ -5382,6 +5382,46 @@
       <p:sp>
         <p:nvSpPr>
           <p:cNvPr id="55" name="TextBox 54"/>
+          <p:cNvSpPr txBox="1"/>
+          <p:nvPr/>
+        </p:nvSpPr>
+        <p:spPr>
+          <a:xfrm>
+            <a:off x="13629132" y="9107424"/>
+            <a:ext cx="3799332" cy="512064"/>
+          </a:xfrm>
+          <a:prstGeom prst="rect">
+            <a:avLst/>
+          </a:prstGeom>
+          <a:noFill/>
+        </p:spPr>
+        <p:txBody>
+          <a:bodyPr wrap="square" anchor="ctr" lIns="0" rIns="0" tIns="0" bIns="0">
+            <a:spAutoFit/>
+          </a:bodyPr>
+          <a:lstStyle/>
+          <a:p>
+            <a:pPr algn="l">
+              <a:lnSpc>
+                <a:spcPct val="100000"/>
+              </a:lnSpc>
+            </a:pPr>
+            <a:r>
+              <a:rPr sz="1500" b="1">
+                <a:solidFill>
+                  <a:srgbClr val="FFFFFF"/>
+                </a:solidFill>
+                <a:latin typeface="Arial"/>
+                <a:ea typeface="Arial"/>
+              </a:rPr>
+              <a:t>④ 직전 성공이 다음 함정: 2019 무감산·HBM</a:t>
+            </a:r>
+          </a:p>
+        </p:txBody>
+      </p:sp>
+      <p:sp>
+        <p:nvSpPr>
+          <p:cNvPr id="56" name="TextBox 55"/>
           <p:cNvSpPr txBox="1"/>
           <p:nvPr/>
         </p:nvSpPr>
@@ -5414,14 +5454,14 @@
                 <a:latin typeface="Arial"/>
                 <a:ea typeface="Arial"/>
               </a:rPr>
-              <a:t>출처: wiki/downturn/downturn-history.md · memory-downturn-history-research-2026-08-22.md (TrendForce·IHS·IC Insights·Gartner 혼합) · * 역산·추정</a:t>
-            </a:r>
-          </a:p>
-        </p:txBody>
-      </p:sp>
-      <p:sp>
-        <p:nvSpPr>
-          <p:cNvPr id="56" name="TextBox 55"/>
+              <a:t>출처: wiki/downturn/downturn-history.md · memory-downturn·nand-market-history-research-2026-08-22.md (기관 혼합 시계열) · * 역산·추정</a:t>
+            </a:r>
+          </a:p>
+        </p:txBody>
+      </p:sp>
+      <p:sp>
+        <p:nvSpPr>
+          <p:cNvPr id="57" name="TextBox 56"/>
           <p:cNvSpPr txBox="1"/>
           <p:nvPr/>
         </p:nvSpPr>
@@ -5924,7 +5964,7 @@
                 <a:latin typeface="Arial"/>
                 <a:ea typeface="Arial"/>
               </a:rPr>
-              <a:t>연매출 낙폭</a:t>
+              <a:t>연매출 낙폭 (DRAM)</a:t>
             </a:r>
           </a:p>
         </p:txBody>
@@ -6522,6 +6562,23 @@
                 <a:ea typeface="Arial"/>
               </a:rPr>
               <a:t>·  업계 전원 적자: 2008년 DRAM 업계 합산 순손실 $7B</a:t>
+            </a:r>
+          </a:p>
+          <a:p>
+            <a:pPr algn="l">
+              <a:lnSpc>
+                <a:spcPct val="112000"/>
+              </a:lnSpc>
+            </a:pPr>
+            <a:r>
+              <a:rPr sz="1725" b="0">
+                <a:solidFill>
+                  <a:srgbClr val="1A1A1A"/>
+                </a:solidFill>
+                <a:latin typeface="Arial"/>
+                <a:ea typeface="Arial"/>
+              </a:rPr>
+              <a:t>·  NAND도 동반 하강: 2008 매출 -14%($13.9B→$12.0B), DRAM보다는 얕음</a:t>
             </a:r>
           </a:p>
         </p:txBody>
@@ -7612,7 +7669,7 @@
                 <a:latin typeface="Arial"/>
                 <a:ea typeface="Arial"/>
               </a:rPr>
-              <a:t>연매출 낙폭</a:t>
+              <a:t>연매출 낙폭 (DRAM)</a:t>
             </a:r>
           </a:p>
         </p:txBody>
@@ -8049,7 +8106,7 @@
                 <a:ea typeface="Arial"/>
               </a:rPr>
               <a:t>DDR3 2Gb 2011년 -85%
-2012 반도체 CapEx 15조 계획(역사이클)</a:t>
+NAND 매출은 보합(-2%*): 모바일 침투가 완충</a:t>
             </a:r>
           </a:p>
         </p:txBody>
@@ -8212,6 +8269,23 @@
               <a:t>·  낙차 대신 지속: 저가 2년이 재무 체력을 소진시키는 침식형</a:t>
             </a:r>
           </a:p>
+          <a:p>
+            <a:pPr algn="l">
+              <a:lnSpc>
+                <a:spcPct val="112000"/>
+              </a:lnSpc>
+            </a:pPr>
+            <a:r>
+              <a:rPr sz="1725" b="0">
+                <a:solidFill>
+                  <a:srgbClr val="1A1A1A"/>
+                </a:solidFill>
+                <a:latin typeface="Arial"/>
+                <a:ea typeface="Arial"/>
+              </a:rPr>
+              <a:t>·  NAND 가격도 원가 이하(31¢/GB): Toshiba 30% 감산(2012-07) 후 +20%</a:t>
+            </a:r>
+          </a:p>
         </p:txBody>
       </p:sp>
       <p:sp>
@@ -8790,7 +8864,7 @@
                 <a:latin typeface="Arial"/>
                 <a:ea typeface="Arial"/>
               </a:rPr>
-              <a:t>출처: wiki/downturn/downturn-history.md · dram-chicken-game-history-2026-08-05.md · memory-capex-history-research-2006-2015-2026-08-15.md · * 역산·추정</a:t>
+              <a:t>출처: wiki/downturn/downturn-history.md · dram-chicken-game-history-2026-08-05.md · nand-market-history-research-2026-08-22.md · * 역산·추정</a:t>
             </a:r>
           </a:p>
         </p:txBody>
@@ -9300,7 +9374,7 @@
                 <a:latin typeface="Arial"/>
                 <a:ea typeface="Arial"/>
               </a:rPr>
-              <a:t>연매출 낙폭</a:t>
+              <a:t>연매출 낙폭 (DRAM)</a:t>
             </a:r>
           </a:p>
         </p:txBody>
@@ -9900,6 +9974,23 @@
               <a:t>·  2H15 재고발 가격 인하 사이클, 저점은 1H16</a:t>
             </a:r>
           </a:p>
+          <a:p>
+            <a:pPr algn="l">
+              <a:lnSpc>
+                <a:spcPct val="112000"/>
+              </a:lnSpc>
+            </a:pPr>
+            <a:r>
+              <a:rPr sz="1725" b="0">
+                <a:solidFill>
+                  <a:srgbClr val="1A1A1A"/>
+                </a:solidFill>
+                <a:latin typeface="Arial"/>
+                <a:ea typeface="Arial"/>
+              </a:rPr>
+              <a:t>·  NAND는 비동행: 3D 전환 제약으로 +14%*, 전체 메모리는 +2%* 유지</a:t>
+            </a:r>
+          </a:p>
         </p:txBody>
       </p:sp>
       <p:sp>
@@ -10478,7 +10569,7 @@
                 <a:latin typeface="Arial"/>
                 <a:ea typeface="Arial"/>
               </a:rPr>
-              <a:t>출처: wiki/downturn/downturn-history.md · memory-downturn-history-research-2026-08-22.md · * 역산·추정</a:t>
+              <a:t>출처: wiki/downturn/downturn-history.md · memory-downturn·nand-market-history-research-2026-08-22.md · * 역산·추정</a:t>
             </a:r>
           </a:p>
         </p:txBody>
@@ -10988,7 +11079,7 @@
                 <a:latin typeface="Arial"/>
                 <a:ea typeface="Arial"/>
               </a:rPr>
-              <a:t>연매출 낙폭</a:t>
+              <a:t>연매출 낙폭 (DRAM)</a:t>
             </a:r>
           </a:p>
         </p:txBody>
@@ -11588,6 +11679,23 @@
               <a:t>·  DRAM 고정가 연간 -50% 이상, 삼성 반도체 영업이익 -69%</a:t>
             </a:r>
           </a:p>
+          <a:p>
+            <a:pPr algn="l">
+              <a:lnSpc>
+                <a:spcPct val="112000"/>
+              </a:lnSpc>
+            </a:pPr>
+            <a:r>
+              <a:rPr sz="1725" b="0">
+                <a:solidFill>
+                  <a:srgbClr val="1A1A1A"/>
+                </a:solidFill>
+                <a:latin typeface="Arial"/>
+                <a:ea typeface="Arial"/>
+              </a:rPr>
+              <a:t>·  NAND 동반 -27%*(4Q18 -16.8% 동시 진입), 정전·감산으로 2H19 먼저 회복</a:t>
+            </a:r>
+          </a:p>
         </p:txBody>
       </p:sp>
       <p:sp>
@@ -12166,7 +12274,7 @@
                 <a:latin typeface="Arial"/>
                 <a:ea typeface="Arial"/>
               </a:rPr>
-              <a:t>출처: wiki/downturn/downturn-history.md · samsung-2019-downturn-2017-2019-actions-2026-08-16.md · * 역산·추정</a:t>
+              <a:t>출처: wiki/downturn/downturn-history.md · samsung-2019-downturn-2017-2019-actions-2026-08-16.md · nand-market-history-research-2026-08-22.md · * 역산·추정</a:t>
             </a:r>
           </a:p>
         </p:txBody>
@@ -12676,7 +12784,7 @@
                 <a:latin typeface="Arial"/>
                 <a:ea typeface="Arial"/>
               </a:rPr>
-              <a:t>연매출 낙폭</a:t>
+              <a:t>연매출 낙폭 (DRAM)</a:t>
             </a:r>
           </a:p>
         </p:txBody>
@@ -13276,6 +13384,23 @@
               <a:t>·  3Q22 -28.9%, 4Q22 -32.5% 연속: 2008년 이후 최대 분기 낙폭</a:t>
             </a:r>
           </a:p>
+          <a:p>
+            <a:pPr algn="l">
+              <a:lnSpc>
+                <a:spcPct val="112000"/>
+              </a:lnSpc>
+            </a:pPr>
+            <a:r>
+              <a:rPr sz="1725" b="0">
+                <a:solidFill>
+                  <a:srgbClr val="1A1A1A"/>
+                </a:solidFill>
+                <a:latin typeface="Arial"/>
+                <a:ea typeface="Arial"/>
+              </a:rPr>
+              <a:t>·  NAND도 -45%($67.1B→$36.7B) 동일 낙폭: D·N 완전 동조화</a:t>
+            </a:r>
+          </a:p>
         </p:txBody>
       </p:sp>
       <p:sp>
@@ -13854,7 +13979,7 @@
                 <a:latin typeface="Arial"/>
                 <a:ea typeface="Arial"/>
               </a:rPr>
-              <a:t>출처: wiki/downturn/downturn-history.md · samsung-downturn-actions-2007-2023-2026-08-07.md · memory-downturn-history-research-2026-08-22.md · * 역산·추정</a:t>
+              <a:t>출처: wiki/downturn/downturn-history.md · samsung-downturn-actions-2007-2023-2026-08-07.md · nand-market-history-research-2026-08-22.md · * 역산·추정</a:t>
             </a:r>
           </a:p>
         </p:txBody>

</xml_diff>